<commit_message>
feat: auto-routing rules (M18) + portal FAQ + bug fixes
- Backend: migration 015, RoutingRule model/schema/service/API (CRUD + test endpoint)
- ticket_service: auto-routing при создании заявки (rule > type default > manual)
- notification_service: добавлен actor_id в SSE payload
- user schema: валидация формата телефона
- Frontend: RoutingRulesTab в Settings, PortalFaqPage, обновлены Sidebar/router
- Docs: дипломная работа v3, презентация, текстовый документ, инструкция доступа

Co-Authored-By: Claude Sonnet 4.6 <noreply@anthropic.com>
</commit_message>
<xml_diff>
--- a/docs/diploma/Презентация_ServiceDesk.pptx
+++ b/docs/diploma/Презентация_ServiceDesk.pptx
@@ -3368,7 +3368,7 @@
         <p:spPr>
           <a:xfrm>
             <a:off x="365760" y="4572000"/>
-            <a:ext cx="7315200" cy="1828800"/>
+            <a:ext cx="7315200" cy="1015663"/>
           </a:xfrm>
           <a:prstGeom prst="rect">
             <a:avLst/>
@@ -3383,14 +3383,134 @@
           <a:p>
             <a:pPr algn="l"/>
             <a:r>
-              <a:rPr sz="1500" b="0" i="0">
+              <a:rPr sz="1500" b="0" i="0" dirty="0" err="1">
                 <a:solidFill>
                   <a:srgbClr val="CCDDEE"/>
                 </a:solidFill>
               </a:rPr>
-              <a:t>Специальность: Информационные системы и программирование
-Студент: Дегтярев М.Д.
-Руководитель: ___________________
+              <a:t>Специальность</a:t>
+            </a:r>
+            <a:r>
+              <a:rPr sz="1500" b="0" i="0" dirty="0">
+                <a:solidFill>
+                  <a:srgbClr val="CCDDEE"/>
+                </a:solidFill>
+              </a:rPr>
+              <a:t>: </a:t>
+            </a:r>
+            <a:r>
+              <a:rPr sz="1500" b="0" i="0" dirty="0" err="1">
+                <a:solidFill>
+                  <a:srgbClr val="CCDDEE"/>
+                </a:solidFill>
+              </a:rPr>
+              <a:t>Информационные</a:t>
+            </a:r>
+            <a:r>
+              <a:rPr sz="1500" b="0" i="0" dirty="0">
+                <a:solidFill>
+                  <a:srgbClr val="CCDDEE"/>
+                </a:solidFill>
+              </a:rPr>
+              <a:t> </a:t>
+            </a:r>
+            <a:r>
+              <a:rPr sz="1500" b="0" i="0" dirty="0" err="1">
+                <a:solidFill>
+                  <a:srgbClr val="CCDDEE"/>
+                </a:solidFill>
+              </a:rPr>
+              <a:t>системы</a:t>
+            </a:r>
+            <a:r>
+              <a:rPr sz="1500" b="0" i="0" dirty="0">
+                <a:solidFill>
+                  <a:srgbClr val="CCDDEE"/>
+                </a:solidFill>
+              </a:rPr>
+              <a:t> и </a:t>
+            </a:r>
+            <a:r>
+              <a:rPr sz="1500" b="0" i="0" dirty="0" err="1">
+                <a:solidFill>
+                  <a:srgbClr val="CCDDEE"/>
+                </a:solidFill>
+              </a:rPr>
+              <a:t>программирование</a:t>
+            </a:r>
+            <a:r>
+              <a:rPr sz="1500" b="0" i="0" dirty="0">
+                <a:solidFill>
+                  <a:srgbClr val="CCDDEE"/>
+                </a:solidFill>
+              </a:rPr>
+              <a:t>
+</a:t>
+            </a:r>
+            <a:r>
+              <a:rPr sz="1500" b="0" i="0" dirty="0" err="1">
+                <a:solidFill>
+                  <a:srgbClr val="CCDDEE"/>
+                </a:solidFill>
+              </a:rPr>
+              <a:t>Студент</a:t>
+            </a:r>
+            <a:r>
+              <a:rPr sz="1500" b="0" i="0" dirty="0">
+                <a:solidFill>
+                  <a:srgbClr val="CCDDEE"/>
+                </a:solidFill>
+              </a:rPr>
+              <a:t>: </a:t>
+            </a:r>
+            <a:r>
+              <a:rPr sz="1500" b="0" i="0" dirty="0" err="1">
+                <a:solidFill>
+                  <a:srgbClr val="CCDDEE"/>
+                </a:solidFill>
+              </a:rPr>
+              <a:t>Дегтярев</a:t>
+            </a:r>
+            <a:r>
+              <a:rPr sz="1500" b="0" i="0" dirty="0">
+                <a:solidFill>
+                  <a:srgbClr val="CCDDEE"/>
+                </a:solidFill>
+              </a:rPr>
+              <a:t> М.Д.
+</a:t>
+            </a:r>
+            <a:r>
+              <a:rPr sz="1500" b="0" i="0" dirty="0" err="1">
+                <a:solidFill>
+                  <a:srgbClr val="CCDDEE"/>
+                </a:solidFill>
+              </a:rPr>
+              <a:t>Руководитель</a:t>
+            </a:r>
+            <a:r>
+              <a:rPr sz="1500" b="0" i="0" dirty="0">
+                <a:solidFill>
+                  <a:srgbClr val="CCDDEE"/>
+                </a:solidFill>
+              </a:rPr>
+              <a:t>: </a:t>
+            </a:r>
+            <a:r>
+              <a:rPr lang="ru-RU" sz="1500" b="0" i="0" dirty="0" smtClean="0">
+                <a:solidFill>
+                  <a:srgbClr val="CCDDEE"/>
+                </a:solidFill>
+              </a:rPr>
+              <a:t>Тараканова А.Д.</a:t>
+            </a:r>
+            <a:r>
+              <a:rPr sz="1500" b="0" i="0" dirty="0">
+                <a:solidFill>
+                  <a:srgbClr val="CCDDEE"/>
+                </a:solidFill>
+              </a:rPr>
+              <a:t>
 2026 г.</a:t>
             </a:r>
           </a:p>
@@ -3401,6 +3521,13 @@
   <p:clrMapOvr>
     <a:masterClrMapping/>
   </p:clrMapOvr>
+  <p:timing>
+    <p:tnLst>
+      <p:par>
+        <p:cTn id="1" dur="indefinite" restart="never" nodeType="tmRoot"/>
+      </p:par>
+    </p:tnLst>
+  </p:timing>
 </p:sld>
 </file>
 
@@ -5746,6 +5873,13 @@
   <p:clrMapOvr>
     <a:masterClrMapping/>
   </p:clrMapOvr>
+  <p:timing>
+    <p:tnLst>
+      <p:par>
+        <p:cTn id="1" dur="indefinite" restart="never" nodeType="tmRoot"/>
+      </p:par>
+    </p:tnLst>
+  </p:timing>
 </p:sld>
 </file>
 
@@ -7289,6 +7423,13 @@
   <p:clrMapOvr>
     <a:masterClrMapping/>
   </p:clrMapOvr>
+  <p:timing>
+    <p:tnLst>
+      <p:par>
+        <p:cTn id="1" dur="indefinite" restart="never" nodeType="tmRoot"/>
+      </p:par>
+    </p:tnLst>
+  </p:timing>
 </p:sld>
 </file>
 
@@ -7509,12 +7650,214 @@
           </a:p>
         </p:txBody>
       </p:sp>
+      <p:sp>
+        <p:nvSpPr>
+          <p:cNvPr id="8" name="TextBox 7"/>
+          <p:cNvSpPr txBox="1"/>
+          <p:nvPr/>
+        </p:nvSpPr>
+        <p:spPr>
+          <a:xfrm>
+            <a:off x="182880" y="3666744"/>
+            <a:ext cx="3794760" cy="274320"/>
+          </a:xfrm>
+          <a:prstGeom prst="rect">
+            <a:avLst/>
+          </a:prstGeom>
+          <a:noFill/>
+        </p:spPr>
+        <p:txBody>
+          <a:bodyPr wrap="square">
+            <a:spAutoFit/>
+          </a:bodyPr>
+          <a:lstStyle/>
+          <a:p>
+            <a:pPr algn="ctr"/>
+            <a:r>
+              <a:rPr sz="1100" b="0" i="0">
+                <a:solidFill>
+                  <a:srgbClr val="556A80"/>
+                </a:solidFill>
+              </a:rPr>
+              <a:t>Вход в систему</a:t>
+            </a:r>
+          </a:p>
+        </p:txBody>
+      </p:sp>
+      <p:sp>
+        <p:nvSpPr>
+          <p:cNvPr id="10" name="TextBox 9"/>
+          <p:cNvSpPr txBox="1"/>
+          <p:nvPr/>
+        </p:nvSpPr>
+        <p:spPr>
+          <a:xfrm>
+            <a:off x="4160520" y="3666744"/>
+            <a:ext cx="3794760" cy="274320"/>
+          </a:xfrm>
+          <a:prstGeom prst="rect">
+            <a:avLst/>
+          </a:prstGeom>
+          <a:noFill/>
+        </p:spPr>
+        <p:txBody>
+          <a:bodyPr wrap="square">
+            <a:spAutoFit/>
+          </a:bodyPr>
+          <a:lstStyle/>
+          <a:p>
+            <a:pPr algn="ctr"/>
+            <a:r>
+              <a:rPr sz="1100" b="0" i="0">
+                <a:solidFill>
+                  <a:srgbClr val="556A80"/>
+                </a:solidFill>
+              </a:rPr>
+              <a:t>Список заявок</a:t>
+            </a:r>
+          </a:p>
+        </p:txBody>
+      </p:sp>
+      <p:sp>
+        <p:nvSpPr>
+          <p:cNvPr id="12" name="TextBox 11"/>
+          <p:cNvSpPr txBox="1"/>
+          <p:nvPr/>
+        </p:nvSpPr>
+        <p:spPr>
+          <a:xfrm>
+            <a:off x="8138160" y="3666744"/>
+            <a:ext cx="3794760" cy="274320"/>
+          </a:xfrm>
+          <a:prstGeom prst="rect">
+            <a:avLst/>
+          </a:prstGeom>
+          <a:noFill/>
+        </p:spPr>
+        <p:txBody>
+          <a:bodyPr wrap="square">
+            <a:spAutoFit/>
+          </a:bodyPr>
+          <a:lstStyle/>
+          <a:p>
+            <a:pPr algn="ctr"/>
+            <a:r>
+              <a:rPr sz="1100" b="0" i="0">
+                <a:solidFill>
+                  <a:srgbClr val="556A80"/>
+                </a:solidFill>
+              </a:rPr>
+              <a:t>Создание заявки</a:t>
+            </a:r>
+          </a:p>
+        </p:txBody>
+      </p:sp>
+      <p:sp>
+        <p:nvSpPr>
+          <p:cNvPr id="14" name="TextBox 13"/>
+          <p:cNvSpPr txBox="1"/>
+          <p:nvPr/>
+        </p:nvSpPr>
+        <p:spPr>
+          <a:xfrm>
+            <a:off x="182880" y="6199632"/>
+            <a:ext cx="3794760" cy="274320"/>
+          </a:xfrm>
+          <a:prstGeom prst="rect">
+            <a:avLst/>
+          </a:prstGeom>
+          <a:noFill/>
+        </p:spPr>
+        <p:txBody>
+          <a:bodyPr wrap="square">
+            <a:spAutoFit/>
+          </a:bodyPr>
+          <a:lstStyle/>
+          <a:p>
+            <a:pPr algn="ctr"/>
+            <a:r>
+              <a:rPr sz="1100" b="0" i="0">
+                <a:solidFill>
+                  <a:srgbClr val="556A80"/>
+                </a:solidFill>
+              </a:rPr>
+              <a:t>Карточка заявки</a:t>
+            </a:r>
+          </a:p>
+        </p:txBody>
+      </p:sp>
+      <p:sp>
+        <p:nvSpPr>
+          <p:cNvPr id="16" name="TextBox 15"/>
+          <p:cNvSpPr txBox="1"/>
+          <p:nvPr/>
+        </p:nvSpPr>
+        <p:spPr>
+          <a:xfrm>
+            <a:off x="4160520" y="6199632"/>
+            <a:ext cx="3794760" cy="274320"/>
+          </a:xfrm>
+          <a:prstGeom prst="rect">
+            <a:avLst/>
+          </a:prstGeom>
+          <a:noFill/>
+        </p:spPr>
+        <p:txBody>
+          <a:bodyPr wrap="square">
+            <a:spAutoFit/>
+          </a:bodyPr>
+          <a:lstStyle/>
+          <a:p>
+            <a:pPr algn="ctr"/>
+            <a:r>
+              <a:rPr sz="1100" b="0" i="0">
+                <a:solidFill>
+                  <a:srgbClr val="556A80"/>
+                </a:solidFill>
+              </a:rPr>
+              <a:t>Отчёты и аналитика</a:t>
+            </a:r>
+          </a:p>
+        </p:txBody>
+      </p:sp>
+      <p:sp>
+        <p:nvSpPr>
+          <p:cNvPr id="18" name="TextBox 17"/>
+          <p:cNvSpPr txBox="1"/>
+          <p:nvPr/>
+        </p:nvSpPr>
+        <p:spPr>
+          <a:xfrm>
+            <a:off x="8138160" y="6199632"/>
+            <a:ext cx="3794760" cy="274320"/>
+          </a:xfrm>
+          <a:prstGeom prst="rect">
+            <a:avLst/>
+          </a:prstGeom>
+          <a:noFill/>
+        </p:spPr>
+        <p:txBody>
+          <a:bodyPr wrap="square">
+            <a:spAutoFit/>
+          </a:bodyPr>
+          <a:lstStyle/>
+          <a:p>
+            <a:pPr algn="ctr"/>
+            <a:r>
+              <a:rPr sz="1100" b="0" i="0">
+                <a:solidFill>
+                  <a:srgbClr val="556A80"/>
+                </a:solidFill>
+              </a:rPr>
+              <a:t>Управление пользователями</a:t>
+            </a:r>
+          </a:p>
+        </p:txBody>
+      </p:sp>
       <p:pic>
         <p:nvPicPr>
-          <p:cNvPr id="7" name="Picture 6" descr="ph_01_login.png"/>
-          <p:cNvPicPr>
-            <a:picLocks noChangeAspect="1"/>
-          </p:cNvPicPr>
+          <p:cNvPr id="19" name="Рисунок 18"/>
+          <p:cNvPicPr/>
           <p:nvPr/>
         </p:nvPicPr>
         <p:blipFill>
@@ -7525,54 +7868,18 @@
         </p:blipFill>
         <p:spPr>
           <a:xfrm>
-            <a:off x="182880" y="1261872"/>
-            <a:ext cx="3794760" cy="2377440"/>
+            <a:off x="0" y="1270217"/>
+            <a:ext cx="4209615" cy="2487967"/>
           </a:xfrm>
           <a:prstGeom prst="rect">
             <a:avLst/>
           </a:prstGeom>
         </p:spPr>
       </p:pic>
-      <p:sp>
-        <p:nvSpPr>
-          <p:cNvPr id="8" name="TextBox 7"/>
-          <p:cNvSpPr txBox="1"/>
-          <p:nvPr/>
-        </p:nvSpPr>
-        <p:spPr>
-          <a:xfrm>
-            <a:off x="182880" y="3666744"/>
-            <a:ext cx="3794760" cy="274320"/>
-          </a:xfrm>
-          <a:prstGeom prst="rect">
-            <a:avLst/>
-          </a:prstGeom>
-          <a:noFill/>
-        </p:spPr>
-        <p:txBody>
-          <a:bodyPr wrap="square">
-            <a:spAutoFit/>
-          </a:bodyPr>
-          <a:lstStyle/>
-          <a:p>
-            <a:pPr algn="ctr"/>
-            <a:r>
-              <a:rPr sz="1100" b="0" i="0">
-                <a:solidFill>
-                  <a:srgbClr val="556A80"/>
-                </a:solidFill>
-              </a:rPr>
-              <a:t>Вход в систему</a:t>
-            </a:r>
-          </a:p>
-        </p:txBody>
-      </p:sp>
       <p:pic>
         <p:nvPicPr>
-          <p:cNvPr id="9" name="Picture 8" descr="ph_02_tickets_list.png"/>
-          <p:cNvPicPr>
-            <a:picLocks noChangeAspect="1"/>
-          </p:cNvPicPr>
+          <p:cNvPr id="20" name="Рисунок 19"/>
+          <p:cNvPicPr/>
           <p:nvPr/>
         </p:nvPicPr>
         <p:blipFill>
@@ -7583,54 +7890,18 @@
         </p:blipFill>
         <p:spPr>
           <a:xfrm>
-            <a:off x="4160520" y="1261872"/>
-            <a:ext cx="3794760" cy="2377440"/>
+            <a:off x="4180051" y="1316433"/>
+            <a:ext cx="3987673" cy="2441751"/>
           </a:xfrm>
           <a:prstGeom prst="rect">
             <a:avLst/>
           </a:prstGeom>
         </p:spPr>
       </p:pic>
-      <p:sp>
-        <p:nvSpPr>
-          <p:cNvPr id="10" name="TextBox 9"/>
-          <p:cNvSpPr txBox="1"/>
-          <p:nvPr/>
-        </p:nvSpPr>
-        <p:spPr>
-          <a:xfrm>
-            <a:off x="4160520" y="3666744"/>
-            <a:ext cx="3794760" cy="274320"/>
-          </a:xfrm>
-          <a:prstGeom prst="rect">
-            <a:avLst/>
-          </a:prstGeom>
-          <a:noFill/>
-        </p:spPr>
-        <p:txBody>
-          <a:bodyPr wrap="square">
-            <a:spAutoFit/>
-          </a:bodyPr>
-          <a:lstStyle/>
-          <a:p>
-            <a:pPr algn="ctr"/>
-            <a:r>
-              <a:rPr sz="1100" b="0" i="0">
-                <a:solidFill>
-                  <a:srgbClr val="556A80"/>
-                </a:solidFill>
-              </a:rPr>
-              <a:t>Список заявок</a:t>
-            </a:r>
-          </a:p>
-        </p:txBody>
-      </p:sp>
       <p:pic>
         <p:nvPicPr>
-          <p:cNvPr id="11" name="Picture 10" descr="ph_03_ticket_create.png"/>
-          <p:cNvPicPr>
-            <a:picLocks noChangeAspect="1"/>
-          </p:cNvPicPr>
+          <p:cNvPr id="21" name="Рисунок 20"/>
+          <p:cNvPicPr/>
           <p:nvPr/>
         </p:nvPicPr>
         <p:blipFill>
@@ -7641,54 +7912,18 @@
         </p:blipFill>
         <p:spPr>
           <a:xfrm>
-            <a:off x="8138160" y="1261872"/>
-            <a:ext cx="3794760" cy="2377440"/>
+            <a:off x="8206163" y="1338796"/>
+            <a:ext cx="3944349" cy="2419388"/>
           </a:xfrm>
           <a:prstGeom prst="rect">
             <a:avLst/>
           </a:prstGeom>
         </p:spPr>
       </p:pic>
-      <p:sp>
-        <p:nvSpPr>
-          <p:cNvPr id="12" name="TextBox 11"/>
-          <p:cNvSpPr txBox="1"/>
-          <p:nvPr/>
-        </p:nvSpPr>
-        <p:spPr>
-          <a:xfrm>
-            <a:off x="8138160" y="3666744"/>
-            <a:ext cx="3794760" cy="274320"/>
-          </a:xfrm>
-          <a:prstGeom prst="rect">
-            <a:avLst/>
-          </a:prstGeom>
-          <a:noFill/>
-        </p:spPr>
-        <p:txBody>
-          <a:bodyPr wrap="square">
-            <a:spAutoFit/>
-          </a:bodyPr>
-          <a:lstStyle/>
-          <a:p>
-            <a:pPr algn="ctr"/>
-            <a:r>
-              <a:rPr sz="1100" b="0" i="0">
-                <a:solidFill>
-                  <a:srgbClr val="556A80"/>
-                </a:solidFill>
-              </a:rPr>
-              <a:t>Создание заявки</a:t>
-            </a:r>
-          </a:p>
-        </p:txBody>
-      </p:sp>
       <p:pic>
         <p:nvPicPr>
-          <p:cNvPr id="13" name="Picture 12" descr="ph_04_ticket_detail.png"/>
-          <p:cNvPicPr>
-            <a:picLocks noChangeAspect="1"/>
-          </p:cNvPicPr>
+          <p:cNvPr id="22" name="Рисунок 21"/>
+          <p:cNvPicPr/>
           <p:nvPr/>
         </p:nvPicPr>
         <p:blipFill>
@@ -7699,54 +7934,18 @@
         </p:blipFill>
         <p:spPr>
           <a:xfrm>
-            <a:off x="182880" y="3794760"/>
-            <a:ext cx="3794760" cy="2377440"/>
+            <a:off x="233393" y="3893021"/>
+            <a:ext cx="3872263" cy="2306612"/>
           </a:xfrm>
           <a:prstGeom prst="rect">
             <a:avLst/>
           </a:prstGeom>
         </p:spPr>
       </p:pic>
-      <p:sp>
-        <p:nvSpPr>
-          <p:cNvPr id="14" name="TextBox 13"/>
-          <p:cNvSpPr txBox="1"/>
-          <p:nvPr/>
-        </p:nvSpPr>
-        <p:spPr>
-          <a:xfrm>
-            <a:off x="182880" y="6199632"/>
-            <a:ext cx="3794760" cy="274320"/>
-          </a:xfrm>
-          <a:prstGeom prst="rect">
-            <a:avLst/>
-          </a:prstGeom>
-          <a:noFill/>
-        </p:spPr>
-        <p:txBody>
-          <a:bodyPr wrap="square">
-            <a:spAutoFit/>
-          </a:bodyPr>
-          <a:lstStyle/>
-          <a:p>
-            <a:pPr algn="ctr"/>
-            <a:r>
-              <a:rPr sz="1100" b="0" i="0">
-                <a:solidFill>
-                  <a:srgbClr val="556A80"/>
-                </a:solidFill>
-              </a:rPr>
-              <a:t>Карточка заявки</a:t>
-            </a:r>
-          </a:p>
-        </p:txBody>
-      </p:sp>
       <p:pic>
         <p:nvPicPr>
-          <p:cNvPr id="15" name="Picture 14" descr="ph_05_reports.png"/>
-          <p:cNvPicPr>
-            <a:picLocks noChangeAspect="1"/>
-          </p:cNvPicPr>
+          <p:cNvPr id="23" name="Рисунок 22"/>
+          <p:cNvPicPr/>
           <p:nvPr/>
         </p:nvPicPr>
         <p:blipFill>
@@ -7757,54 +7956,18 @@
         </p:blipFill>
         <p:spPr>
           <a:xfrm>
-            <a:off x="4160520" y="3794760"/>
-            <a:ext cx="3794760" cy="2377440"/>
+            <a:off x="4180051" y="3941063"/>
+            <a:ext cx="3987673" cy="2258569"/>
           </a:xfrm>
           <a:prstGeom prst="rect">
             <a:avLst/>
           </a:prstGeom>
         </p:spPr>
       </p:pic>
-      <p:sp>
-        <p:nvSpPr>
-          <p:cNvPr id="16" name="TextBox 15"/>
-          <p:cNvSpPr txBox="1"/>
-          <p:nvPr/>
-        </p:nvSpPr>
-        <p:spPr>
-          <a:xfrm>
-            <a:off x="4160520" y="6199632"/>
-            <a:ext cx="3794760" cy="274320"/>
-          </a:xfrm>
-          <a:prstGeom prst="rect">
-            <a:avLst/>
-          </a:prstGeom>
-          <a:noFill/>
-        </p:spPr>
-        <p:txBody>
-          <a:bodyPr wrap="square">
-            <a:spAutoFit/>
-          </a:bodyPr>
-          <a:lstStyle/>
-          <a:p>
-            <a:pPr algn="ctr"/>
-            <a:r>
-              <a:rPr sz="1100" b="0" i="0">
-                <a:solidFill>
-                  <a:srgbClr val="556A80"/>
-                </a:solidFill>
-              </a:rPr>
-              <a:t>Отчёты и аналитика</a:t>
-            </a:r>
-          </a:p>
-        </p:txBody>
-      </p:sp>
       <p:pic>
         <p:nvPicPr>
-          <p:cNvPr id="17" name="Picture 16" descr="ph_06_admin_users.png"/>
-          <p:cNvPicPr>
-            <a:picLocks noChangeAspect="1"/>
-          </p:cNvPicPr>
+          <p:cNvPr id="24" name="Рисунок 23"/>
+          <p:cNvPicPr/>
           <p:nvPr/>
         </p:nvPicPr>
         <p:blipFill>
@@ -7815,53 +7978,26 @@
         </p:blipFill>
         <p:spPr>
           <a:xfrm>
-            <a:off x="8138160" y="3794760"/>
-            <a:ext cx="3794760" cy="2377440"/>
+            <a:off x="8242120" y="3986784"/>
+            <a:ext cx="3840390" cy="2209894"/>
           </a:xfrm>
           <a:prstGeom prst="rect">
             <a:avLst/>
           </a:prstGeom>
         </p:spPr>
       </p:pic>
-      <p:sp>
-        <p:nvSpPr>
-          <p:cNvPr id="18" name="TextBox 17"/>
-          <p:cNvSpPr txBox="1"/>
-          <p:nvPr/>
-        </p:nvSpPr>
-        <p:spPr>
-          <a:xfrm>
-            <a:off x="8138160" y="6199632"/>
-            <a:ext cx="3794760" cy="274320"/>
-          </a:xfrm>
-          <a:prstGeom prst="rect">
-            <a:avLst/>
-          </a:prstGeom>
-          <a:noFill/>
-        </p:spPr>
-        <p:txBody>
-          <a:bodyPr wrap="square">
-            <a:spAutoFit/>
-          </a:bodyPr>
-          <a:lstStyle/>
-          <a:p>
-            <a:pPr algn="ctr"/>
-            <a:r>
-              <a:rPr sz="1100" b="0" i="0">
-                <a:solidFill>
-                  <a:srgbClr val="556A80"/>
-                </a:solidFill>
-              </a:rPr>
-              <a:t>Управление пользователями</a:t>
-            </a:r>
-          </a:p>
-        </p:txBody>
-      </p:sp>
     </p:spTree>
   </p:cSld>
   <p:clrMapOvr>
     <a:masterClrMapping/>
   </p:clrMapOvr>
+  <p:timing>
+    <p:tnLst>
+      <p:par>
+        <p:cTn id="1" dur="indefinite" restart="never" nodeType="tmRoot"/>
+      </p:par>
+    </p:tnLst>
+  </p:timing>
 </p:sld>
 </file>
 
@@ -8111,6 +8247,13 @@
   <p:clrMapOvr>
     <a:masterClrMapping/>
   </p:clrMapOvr>
+  <p:timing>
+    <p:tnLst>
+      <p:par>
+        <p:cTn id="1" dur="indefinite" restart="never" nodeType="tmRoot"/>
+      </p:par>
+    </p:tnLst>
+  </p:timing>
 </p:sld>
 </file>
 
@@ -8517,13 +8660,66 @@
           <a:p>
             <a:pPr algn="ctr"/>
             <a:r>
-              <a:rPr sz="2200" b="1" i="0">
+              <a:rPr sz="2200" b="1" i="0" dirty="0" err="1">
                 <a:solidFill>
                   <a:srgbClr val="2196F3"/>
                 </a:solidFill>
               </a:rPr>
-              <a:t>Система готова к промышленной эксплуатации</a:t>
-            </a:r>
+              <a:t>Система</a:t>
+            </a:r>
+            <a:r>
+              <a:rPr sz="2200" b="1" i="0" dirty="0">
+                <a:solidFill>
+                  <a:srgbClr val="2196F3"/>
+                </a:solidFill>
+              </a:rPr>
+              <a:t> </a:t>
+            </a:r>
+            <a:r>
+              <a:rPr sz="2200" b="1" i="0" dirty="0" err="1">
+                <a:solidFill>
+                  <a:srgbClr val="2196F3"/>
+                </a:solidFill>
+              </a:rPr>
+              <a:t>готова</a:t>
+            </a:r>
+            <a:r>
+              <a:rPr sz="2200" b="1" i="0" dirty="0">
+                <a:solidFill>
+                  <a:srgbClr val="2196F3"/>
+                </a:solidFill>
+              </a:rPr>
+              <a:t> к </a:t>
+            </a:r>
+            <a:r>
+              <a:rPr sz="2200" b="1" i="0" dirty="0" err="1">
+                <a:solidFill>
+                  <a:srgbClr val="2196F3"/>
+                </a:solidFill>
+              </a:rPr>
+              <a:t>промышленной</a:t>
+            </a:r>
+            <a:r>
+              <a:rPr sz="2200" b="1" i="0" dirty="0">
+                <a:solidFill>
+                  <a:srgbClr val="2196F3"/>
+                </a:solidFill>
+              </a:rPr>
+              <a:t> </a:t>
+            </a:r>
+            <a:r>
+              <a:rPr sz="2200" b="1" i="0" dirty="0" err="1">
+                <a:solidFill>
+                  <a:srgbClr val="2196F3"/>
+                </a:solidFill>
+              </a:rPr>
+              <a:t>эксплуатации</a:t>
+            </a:r>
+            <a:endParaRPr sz="2200" b="1" i="0" dirty="0">
+              <a:solidFill>
+                <a:srgbClr val="2196F3"/>
+              </a:solidFill>
+            </a:endParaRPr>
           </a:p>
         </p:txBody>
       </p:sp>
@@ -8536,7 +8732,7 @@
         <p:spPr>
           <a:xfrm>
             <a:off x="365760" y="4937760"/>
-            <a:ext cx="11430000" cy="640080"/>
+            <a:ext cx="11430000" cy="584775"/>
           </a:xfrm>
           <a:prstGeom prst="rect">
             <a:avLst/>
@@ -8550,14 +8746,11 @@
           <a:lstStyle/>
           <a:p>
             <a:pPr algn="ctr"/>
-            <a:r>
-              <a:rPr sz="3200" b="1" i="0">
-                <a:solidFill>
-                  <a:srgbClr val="FFFFFF"/>
-                </a:solidFill>
-              </a:rPr>
-              <a:t>Спасибо за внимание!</a:t>
-            </a:r>
+            <a:endParaRPr sz="3200" b="1" i="0" dirty="0">
+              <a:solidFill>
+                <a:srgbClr val="FFFFFF"/>
+              </a:solidFill>
+            </a:endParaRPr>
           </a:p>
         </p:txBody>
       </p:sp>
@@ -8570,7 +8763,7 @@
         <p:spPr>
           <a:xfrm>
             <a:off x="365760" y="5577840"/>
-            <a:ext cx="11430000" cy="457200"/>
+            <a:ext cx="11430000" cy="400110"/>
           </a:xfrm>
           <a:prstGeom prst="rect">
             <a:avLst/>
@@ -8584,14 +8777,11 @@
           <a:lstStyle/>
           <a:p>
             <a:pPr algn="ctr"/>
-            <a:r>
-              <a:rPr sz="2000" b="0" i="0">
-                <a:solidFill>
-                  <a:srgbClr val="AACCEE"/>
-                </a:solidFill>
-              </a:rPr>
-              <a:t>Вопросы?</a:t>
-            </a:r>
+            <a:endParaRPr sz="2000" b="0" i="0" dirty="0">
+              <a:solidFill>
+                <a:srgbClr val="AACCEE"/>
+              </a:solidFill>
+            </a:endParaRPr>
           </a:p>
         </p:txBody>
       </p:sp>
@@ -8600,6 +8790,13 @@
   <p:clrMapOvr>
     <a:masterClrMapping/>
   </p:clrMapOvr>
+  <p:timing>
+    <p:tnLst>
+      <p:par>
+        <p:cTn id="1" dur="indefinite" restart="never" nodeType="tmRoot"/>
+      </p:par>
+    </p:tnLst>
+  </p:timing>
 </p:sld>
 </file>
 
@@ -9201,6 +9398,13 @@
   <p:clrMapOvr>
     <a:masterClrMapping/>
   </p:clrMapOvr>
+  <p:timing>
+    <p:tnLst>
+      <p:par>
+        <p:cTn id="1" dur="indefinite" restart="never" nodeType="tmRoot"/>
+      </p:par>
+    </p:tnLst>
+  </p:timing>
 </p:sld>
 </file>
 
@@ -10047,6 +10251,13 @@
   <p:clrMapOvr>
     <a:masterClrMapping/>
   </p:clrMapOvr>
+  <p:timing>
+    <p:tnLst>
+      <p:par>
+        <p:cTn id="1" dur="indefinite" restart="never" nodeType="tmRoot"/>
+      </p:par>
+    </p:tnLst>
+  </p:timing>
 </p:sld>
 </file>
 
@@ -10939,6 +11150,13 @@
   <p:clrMapOvr>
     <a:masterClrMapping/>
   </p:clrMapOvr>
+  <p:timing>
+    <p:tnLst>
+      <p:par>
+        <p:cTn id="1" dur="indefinite" restart="never" nodeType="tmRoot"/>
+      </p:par>
+    </p:tnLst>
+  </p:timing>
 </p:sld>
 </file>
 
@@ -11167,16 +11385,15 @@
           </p:cNvPicPr>
           <p:nvPr/>
         </p:nvPicPr>
-        <p:blipFill>
+        <p:blipFill rotWithShape="1">
           <a:blip r:embed="rId2"/>
-          <a:stretch>
-            <a:fillRect/>
-          </a:stretch>
+          <a:srcRect t="9446"/>
+          <a:stretch/>
         </p:blipFill>
         <p:spPr>
           <a:xfrm>
-            <a:off x="274320" y="1234440"/>
-            <a:ext cx="11612880" cy="5394960"/>
+            <a:off x="365760" y="594804"/>
+            <a:ext cx="11521440" cy="6263196"/>
           </a:xfrm>
           <a:prstGeom prst="rect">
             <a:avLst/>
@@ -11188,6 +11405,13 @@
   <p:clrMapOvr>
     <a:masterClrMapping/>
   </p:clrMapOvr>
+  <p:timing>
+    <p:tnLst>
+      <p:par>
+        <p:cTn id="1" dur="indefinite" restart="never" nodeType="tmRoot"/>
+      </p:par>
+    </p:tnLst>
+  </p:timing>
 </p:sld>
 </file>
 
@@ -11437,6 +11661,13 @@
   <p:clrMapOvr>
     <a:masterClrMapping/>
   </p:clrMapOvr>
+  <p:timing>
+    <p:tnLst>
+      <p:par>
+        <p:cTn id="1" dur="indefinite" restart="never" nodeType="tmRoot"/>
+      </p:par>
+    </p:tnLst>
+  </p:timing>
 </p:sld>
 </file>
 
@@ -11686,6 +11917,13 @@
   <p:clrMapOvr>
     <a:masterClrMapping/>
   </p:clrMapOvr>
+  <p:timing>
+    <p:tnLst>
+      <p:par>
+        <p:cTn id="1" dur="indefinite" restart="never" nodeType="tmRoot"/>
+      </p:par>
+    </p:tnLst>
+  </p:timing>
 </p:sld>
 </file>
 
@@ -11935,6 +12173,13 @@
   <p:clrMapOvr>
     <a:masterClrMapping/>
   </p:clrMapOvr>
+  <p:timing>
+    <p:tnLst>
+      <p:par>
+        <p:cTn id="1" dur="indefinite" restart="never" nodeType="tmRoot"/>
+      </p:par>
+    </p:tnLst>
+  </p:timing>
 </p:sld>
 </file>
 
@@ -12184,6 +12429,13 @@
   <p:clrMapOvr>
     <a:masterClrMapping/>
   </p:clrMapOvr>
+  <p:timing>
+    <p:tnLst>
+      <p:par>
+        <p:cTn id="1" dur="indefinite" restart="never" nodeType="tmRoot"/>
+      </p:par>
+    </p:tnLst>
+  </p:timing>
 </p:sld>
 </file>
 

</xml_diff>